<commit_message>
docs(presentation): clarify Mac to Windows live evidence
</commit_message>
<xml_diff>
--- a/presentation/ollama-cross-machine-demo-v4.pptx
+++ b/presentation/ollama-cross-machine-demo-v4.pptx
@@ -2,15 +2,15 @@
 <file path=ppt/presentation.xml><?xml version="1.0" encoding="utf-8"?>
 <p:presentation xmlns:p="http://schemas.openxmlformats.org/presentationml/2006/main">
   <p:sldMasterIdLst>
-    <p:sldMasterId xmlns:r="http://schemas.openxmlformats.org/officeDocument/2006/relationships" id="2147483648" r:id="Rcfc658ec5aaf4e65"/>
+    <p:sldMasterId xmlns:r="http://schemas.openxmlformats.org/officeDocument/2006/relationships" id="2147483648" r:id="R5710fb1adbd3468a"/>
   </p:sldMasterIdLst>
   <p:notesMasterIdLst>
-    <p:notesMasterId xmlns:r="http://schemas.openxmlformats.org/officeDocument/2006/relationships" r:id="Ra939eb3ae6c74d9a"/>
+    <p:notesMasterId xmlns:r="http://schemas.openxmlformats.org/officeDocument/2006/relationships" r:id="R59106d26b52346d6"/>
   </p:notesMasterIdLst>
   <p:sldIdLst>
-    <p:sldId xmlns:r="http://schemas.openxmlformats.org/officeDocument/2006/relationships" id="256" r:id="R92a0d14f1b4d4623"/>
-    <p:sldId xmlns:r="http://schemas.openxmlformats.org/officeDocument/2006/relationships" id="257" r:id="R2b354aecff814b56"/>
-    <p:sldId xmlns:r="http://schemas.openxmlformats.org/officeDocument/2006/relationships" id="258" r:id="Rcfff40dfee9e4816"/>
+    <p:sldId xmlns:r="http://schemas.openxmlformats.org/officeDocument/2006/relationships" id="256" r:id="R9ffecc3bc2e94fd5"/>
+    <p:sldId xmlns:r="http://schemas.openxmlformats.org/officeDocument/2006/relationships" id="257" r:id="R4d39268054934d5e"/>
+    <p:sldId xmlns:r="http://schemas.openxmlformats.org/officeDocument/2006/relationships" id="258" r:id="R0acb919cd6c8476a"/>
   </p:sldIdLst>
   <p:sldSz cx="12192000" cy="6858000"/>
   <p:notesSz cx="6858000" cy="9144000"/>
@@ -652,7 +652,7 @@
   </p:cSld>
   <p:clrMap bg1="lt1" tx1="dk1" bg2="lt2" tx2="dk2" accent1="accent1" accent2="accent2" accent3="accent3" accent4="accent4" accent5="accent5" accent6="accent6" hlink="hlink" folHlink="folHlink"/>
   <p:sldLayoutIdLst>
-    <p:sldLayoutId xmlns:r="http://schemas.openxmlformats.org/officeDocument/2006/relationships" id="2147483649" r:id="R41bd058c02a04869"/>
+    <p:sldLayoutId xmlns:r="http://schemas.openxmlformats.org/officeDocument/2006/relationships" id="2147483649" r:id="R91de172f04164590"/>
   </p:sldLayoutIdLst>
   <p:txStyles>
     <p:titleStyle>
@@ -1831,7 +1831,7 @@
           <p:cNvPr id="29" name="">
             <a:extLst xmlns:a="http://schemas.openxmlformats.org/drawingml/2006/main">
               <a:ext uri="{FF2B5EF4-FFF2-40B4-BE49-F238E27FC236}">
-                <a16:creationId xmlns:a16="http://schemas.microsoft.com/office/drawing/2014/main" id="{BBE57966-229C-4227-A03E-6217582B1DEC}"/>
+                <a16:creationId xmlns:a16="http://schemas.microsoft.com/office/drawing/2014/main" id="{FEE413DD-A0D9-4E6D-83FB-7113D1E63C95}"/>
               </a:ext>
             </a:extLst>
           </p:cNvPr>
@@ -2267,7 +2267,7 @@
                 <a:ea typeface="STHeiti"/>
                 <a:cs typeface="STHeiti"/>
               </a:rPr>
-              <a:t>Mac 端已記錄實跑</a:t>
+              <a:t>Mac → Windows 跨機實跑</a:t>
             </a:r>
           </a:p>
         </p:txBody>
@@ -2336,7 +2336,7 @@
           <p:cNvPr id="19" name="">
             <a:extLst xmlns:a="http://schemas.openxmlformats.org/drawingml/2006/main">
               <a:ext uri="{FF2B5EF4-FFF2-40B4-BE49-F238E27FC236}">
-                <a16:creationId xmlns:a16="http://schemas.microsoft.com/office/drawing/2014/main" id="{0B403052-68EF-4C2F-B4AC-68AD2CAE850D}"/>
+                <a16:creationId xmlns:a16="http://schemas.microsoft.com/office/drawing/2014/main" id="{8A8E16C1-108A-44D4-B9A8-9FF17B937194}"/>
               </a:ext>
             </a:extLst>
           </p:cNvPr>
@@ -2346,7 +2346,7 @@
           <p:nvPr/>
         </p:nvPicPr>
         <p:blipFill>
-          <a:blip xmlns:r="http://schemas.openxmlformats.org/officeDocument/2006/relationships" xmlns:a="http://schemas.openxmlformats.org/drawingml/2006/main" r:embed="Rf3c9a9bf295a4371"/>
+          <a:blip xmlns:r="http://schemas.openxmlformats.org/officeDocument/2006/relationships" xmlns:a="http://schemas.openxmlformats.org/drawingml/2006/main" r:embed="Rd8f6138c55284656"/>
           <a:stretch xmlns:a="http://schemas.openxmlformats.org/drawingml/2006/main"/>
         </p:blipFill>
         <p:spPr>
@@ -2586,7 +2586,7 @@
                 <a:ea typeface="STHeiti"/>
                 <a:cs typeface="STHeiti"/>
               </a:rPr>
-              <a:t>兩圖皆為真實輸出呈現，非視窗直拍；本次 Mac 跨機排練待完成。</a:t>
+              <a:t>Mac 直接呼叫 Windows Ollama，已完成跨機實際操作；兩圖非視窗直拍。</a:t>
             </a:r>
           </a:p>
         </p:txBody>
@@ -2596,7 +2596,7 @@
           <p:cNvPr id="20" name="">
             <a:extLst xmlns:a="http://schemas.openxmlformats.org/drawingml/2006/main">
               <a:ext uri="{FF2B5EF4-FFF2-40B4-BE49-F238E27FC236}">
-                <a16:creationId xmlns:a16="http://schemas.microsoft.com/office/drawing/2014/main" id="{4349F58E-86F2-4F63-B898-1D3A2456812D}"/>
+                <a16:creationId xmlns:a16="http://schemas.microsoft.com/office/drawing/2014/main" id="{F69CBD64-0E10-4085-939B-3F55759C0C41}"/>
               </a:ext>
             </a:extLst>
           </p:cNvPr>
@@ -2606,7 +2606,7 @@
           <p:nvPr/>
         </p:nvPicPr>
         <p:blipFill>
-          <a:blip xmlns:r="http://schemas.openxmlformats.org/officeDocument/2006/relationships" xmlns:a="http://schemas.openxmlformats.org/drawingml/2006/main" r:embed="R51ca3ce79820445e"/>
+          <a:blip xmlns:r="http://schemas.openxmlformats.org/officeDocument/2006/relationships" xmlns:a="http://schemas.openxmlformats.org/drawingml/2006/main" r:embed="R7435aba8190b4b83"/>
           <a:stretch xmlns:a="http://schemas.openxmlformats.org/drawingml/2006/main"/>
         </p:blipFill>
         <p:spPr>
@@ -3534,7 +3534,7 @@
                 <a:ea typeface="STHeiti"/>
                 <a:cs typeface="STHeiti"/>
               </a:rPr>
-              <a:t>主機對應由使用者確認；客戶展示前仍需完成本次跨機排練。</a:t>
+              <a:t>已有 Mac → Windows 跨機實跑證據；客戶展示前建議再排練一次。</a:t>
             </a:r>
           </a:p>
         </p:txBody>

</xml_diff>